<commit_message>
Product Details - Show dynamic contents at details page (part - 3)
</commit_message>
<xml_diff>
--- a/.lessons/62 Product Details Page/2 Product Details - Show dynamic contents at details page (part - 2)/1.pptx
+++ b/.lessons/62 Product Details Page/2 Product Details - Show dynamic contents at details page (part - 2)/1.pptx
@@ -7,9 +7,16 @@
   <p:sldIdLst>
     <p:sldId id="415" r:id="rId2"/>
     <p:sldId id="416" r:id="rId3"/>
-    <p:sldId id="417" r:id="rId4"/>
-    <p:sldId id="418" r:id="rId5"/>
-    <p:sldId id="419" r:id="rId6"/>
+    <p:sldId id="420" r:id="rId4"/>
+    <p:sldId id="421" r:id="rId5"/>
+    <p:sldId id="417" r:id="rId6"/>
+    <p:sldId id="423" r:id="rId7"/>
+    <p:sldId id="424" r:id="rId8"/>
+    <p:sldId id="425" r:id="rId9"/>
+    <p:sldId id="426" r:id="rId10"/>
+    <p:sldId id="427" r:id="rId11"/>
+    <p:sldId id="418" r:id="rId12"/>
+    <p:sldId id="419" r:id="rId13"/>
   </p:sldIdLst>
   <p:sldSz cx="12192000" cy="6858000"/>
   <p:notesSz cx="6858000" cy="9144000"/>
@@ -263,7 +270,7 @@
           <a:p>
             <a:fld id="{3E102D2E-813C-461C-9963-687A650C48C0}" type="datetimeFigureOut">
               <a:rPr lang="en-US" smtClean="0"/>
-              <a:t>12/24/2025</a:t>
+              <a:t>12/28/2025</a:t>
             </a:fld>
             <a:endParaRPr lang="en-US"/>
           </a:p>
@@ -461,7 +468,7 @@
           <a:p>
             <a:fld id="{3E102D2E-813C-461C-9963-687A650C48C0}" type="datetimeFigureOut">
               <a:rPr lang="en-US" smtClean="0"/>
-              <a:t>12/24/2025</a:t>
+              <a:t>12/28/2025</a:t>
             </a:fld>
             <a:endParaRPr lang="en-US"/>
           </a:p>
@@ -669,7 +676,7 @@
           <a:p>
             <a:fld id="{3E102D2E-813C-461C-9963-687A650C48C0}" type="datetimeFigureOut">
               <a:rPr lang="en-US" smtClean="0"/>
-              <a:t>12/24/2025</a:t>
+              <a:t>12/28/2025</a:t>
             </a:fld>
             <a:endParaRPr lang="en-US"/>
           </a:p>
@@ -867,7 +874,7 @@
           <a:p>
             <a:fld id="{3E102D2E-813C-461C-9963-687A650C48C0}" type="datetimeFigureOut">
               <a:rPr lang="en-US" smtClean="0"/>
-              <a:t>12/24/2025</a:t>
+              <a:t>12/28/2025</a:t>
             </a:fld>
             <a:endParaRPr lang="en-US"/>
           </a:p>
@@ -1142,7 +1149,7 @@
           <a:p>
             <a:fld id="{3E102D2E-813C-461C-9963-687A650C48C0}" type="datetimeFigureOut">
               <a:rPr lang="en-US" smtClean="0"/>
-              <a:t>12/24/2025</a:t>
+              <a:t>12/28/2025</a:t>
             </a:fld>
             <a:endParaRPr lang="en-US"/>
           </a:p>
@@ -1407,7 +1414,7 @@
           <a:p>
             <a:fld id="{3E102D2E-813C-461C-9963-687A650C48C0}" type="datetimeFigureOut">
               <a:rPr lang="en-US" smtClean="0"/>
-              <a:t>12/24/2025</a:t>
+              <a:t>12/28/2025</a:t>
             </a:fld>
             <a:endParaRPr lang="en-US"/>
           </a:p>
@@ -1819,7 +1826,7 @@
           <a:p>
             <a:fld id="{3E102D2E-813C-461C-9963-687A650C48C0}" type="datetimeFigureOut">
               <a:rPr lang="en-US" smtClean="0"/>
-              <a:t>12/24/2025</a:t>
+              <a:t>12/28/2025</a:t>
             </a:fld>
             <a:endParaRPr lang="en-US"/>
           </a:p>
@@ -1960,7 +1967,7 @@
           <a:p>
             <a:fld id="{3E102D2E-813C-461C-9963-687A650C48C0}" type="datetimeFigureOut">
               <a:rPr lang="en-US" smtClean="0"/>
-              <a:t>12/24/2025</a:t>
+              <a:t>12/28/2025</a:t>
             </a:fld>
             <a:endParaRPr lang="en-US"/>
           </a:p>
@@ -2073,7 +2080,7 @@
           <a:p>
             <a:fld id="{3E102D2E-813C-461C-9963-687A650C48C0}" type="datetimeFigureOut">
               <a:rPr lang="en-US" smtClean="0"/>
-              <a:t>12/24/2025</a:t>
+              <a:t>12/28/2025</a:t>
             </a:fld>
             <a:endParaRPr lang="en-US"/>
           </a:p>
@@ -2384,7 +2391,7 @@
           <a:p>
             <a:fld id="{3E102D2E-813C-461C-9963-687A650C48C0}" type="datetimeFigureOut">
               <a:rPr lang="en-US" smtClean="0"/>
-              <a:t>12/24/2025</a:t>
+              <a:t>12/28/2025</a:t>
             </a:fld>
             <a:endParaRPr lang="en-US"/>
           </a:p>
@@ -2672,7 +2679,7 @@
           <a:p>
             <a:fld id="{3E102D2E-813C-461C-9963-687A650C48C0}" type="datetimeFigureOut">
               <a:rPr lang="en-US" smtClean="0"/>
-              <a:t>12/24/2025</a:t>
+              <a:t>12/28/2025</a:t>
             </a:fld>
             <a:endParaRPr lang="en-US"/>
           </a:p>
@@ -2913,7 +2920,7 @@
           <a:p>
             <a:fld id="{3E102D2E-813C-461C-9963-687A650C48C0}" type="datetimeFigureOut">
               <a:rPr lang="en-US" smtClean="0"/>
-              <a:t>12/24/2025</a:t>
+              <a:t>12/28/2025</a:t>
             </a:fld>
             <a:endParaRPr lang="en-US"/>
           </a:p>
@@ -3386,10 +3393,358 @@
           </a:p>
         </p:txBody>
       </p:sp>
+      <p:pic>
+        <p:nvPicPr>
+          <p:cNvPr id="4" name="Picture 3">
+            <a:extLst>
+              <a:ext uri="{FF2B5EF4-FFF2-40B4-BE49-F238E27FC236}">
+                <a16:creationId xmlns:a16="http://schemas.microsoft.com/office/drawing/2014/main" id="{BDBE8A8A-B749-A2B6-B7A9-E4B0C5350EAB}"/>
+              </a:ext>
+            </a:extLst>
+          </p:cNvPr>
+          <p:cNvPicPr>
+            <a:picLocks noChangeAspect="1"/>
+          </p:cNvPicPr>
+          <p:nvPr/>
+        </p:nvPicPr>
+        <p:blipFill>
+          <a:blip r:embed="rId2"/>
+          <a:stretch>
+            <a:fillRect/>
+          </a:stretch>
+        </p:blipFill>
+        <p:spPr>
+          <a:xfrm>
+            <a:off x="3243184" y="0"/>
+            <a:ext cx="5705631" cy="6858000"/>
+          </a:xfrm>
+          <a:prstGeom prst="rect">
+            <a:avLst/>
+          </a:prstGeom>
+        </p:spPr>
+      </p:pic>
     </p:spTree>
     <p:extLst>
       <p:ext uri="{BB962C8B-B14F-4D97-AF65-F5344CB8AC3E}">
         <p14:creationId xmlns:p14="http://schemas.microsoft.com/office/powerpoint/2010/main" val="3737127349"/>
+      </p:ext>
+    </p:extLst>
+  </p:cSld>
+  <p:clrMapOvr>
+    <a:masterClrMapping/>
+  </p:clrMapOvr>
+</p:sld>
+</file>
+
+<file path=ppt/slides/slide10.xml><?xml version="1.0" encoding="utf-8"?>
+<p:sld xmlns:a="http://schemas.openxmlformats.org/drawingml/2006/main" xmlns:r="http://schemas.openxmlformats.org/officeDocument/2006/relationships" xmlns:p="http://schemas.openxmlformats.org/presentationml/2006/main">
+  <p:cSld>
+    <p:spTree>
+      <p:nvGrpSpPr>
+        <p:cNvPr id="1" name="">
+          <a:extLst>
+            <a:ext uri="{FF2B5EF4-FFF2-40B4-BE49-F238E27FC236}">
+              <a16:creationId xmlns:a16="http://schemas.microsoft.com/office/drawing/2014/main" id="{EBE5FF3D-F9A2-2745-4F20-6BB846F7EEBE}"/>
+            </a:ext>
+          </a:extLst>
+        </p:cNvPr>
+        <p:cNvGrpSpPr/>
+        <p:nvPr/>
+      </p:nvGrpSpPr>
+      <p:grpSpPr>
+        <a:xfrm>
+          <a:off x="0" y="0"/>
+          <a:ext cx="0" cy="0"/>
+          <a:chOff x="0" y="0"/>
+          <a:chExt cx="0" cy="0"/>
+        </a:xfrm>
+      </p:grpSpPr>
+      <p:sp>
+        <p:nvSpPr>
+          <p:cNvPr id="3" name="TextBox 2">
+            <a:extLst>
+              <a:ext uri="{FF2B5EF4-FFF2-40B4-BE49-F238E27FC236}">
+                <a16:creationId xmlns:a16="http://schemas.microsoft.com/office/drawing/2014/main" id="{E4A87F58-D499-F1A2-9B18-CDF873ACB077}"/>
+              </a:ext>
+            </a:extLst>
+          </p:cNvPr>
+          <p:cNvSpPr txBox="1"/>
+          <p:nvPr/>
+        </p:nvSpPr>
+        <p:spPr>
+          <a:xfrm>
+            <a:off x="0" y="0"/>
+            <a:ext cx="12192000" cy="355354"/>
+          </a:xfrm>
+          <a:prstGeom prst="rect">
+            <a:avLst/>
+          </a:prstGeom>
+          <a:noFill/>
+        </p:spPr>
+        <p:txBody>
+          <a:bodyPr wrap="square">
+            <a:spAutoFit/>
+          </a:bodyPr>
+          <a:lstStyle/>
+          <a:p>
+            <a:pPr>
+              <a:lnSpc>
+                <a:spcPct val="150000"/>
+              </a:lnSpc>
+              <a:buNone/>
+            </a:pPr>
+            <a:r>
+              <a:rPr kumimoji="0" lang="en-US" altLang="en-US" sz="1300" b="0" i="0" u="none" strike="noStrike" cap="none" normalizeH="0" baseline="0">
+                <a:ln>
+                  <a:noFill/>
+                </a:ln>
+                <a:solidFill>
+                  <a:schemeClr val="tx1"/>
+                </a:solidFill>
+                <a:effectLst/>
+                <a:latin typeface="Arial" panose="020B0604020202020204" pitchFamily="34" charset="0"/>
+              </a:rPr>
+              <a:t>.</a:t>
+            </a:r>
+          </a:p>
+        </p:txBody>
+      </p:sp>
+      <p:pic>
+        <p:nvPicPr>
+          <p:cNvPr id="4" name="Picture 3">
+            <a:extLst>
+              <a:ext uri="{FF2B5EF4-FFF2-40B4-BE49-F238E27FC236}">
+                <a16:creationId xmlns:a16="http://schemas.microsoft.com/office/drawing/2014/main" id="{551D9EB8-E736-D53E-9D03-CD619D3B4DC1}"/>
+              </a:ext>
+            </a:extLst>
+          </p:cNvPr>
+          <p:cNvPicPr>
+            <a:picLocks noChangeAspect="1"/>
+          </p:cNvPicPr>
+          <p:nvPr/>
+        </p:nvPicPr>
+        <p:blipFill>
+          <a:blip r:embed="rId2"/>
+          <a:stretch>
+            <a:fillRect/>
+          </a:stretch>
+        </p:blipFill>
+        <p:spPr>
+          <a:xfrm>
+            <a:off x="0" y="432903"/>
+            <a:ext cx="12192000" cy="5992193"/>
+          </a:xfrm>
+          <a:prstGeom prst="rect">
+            <a:avLst/>
+          </a:prstGeom>
+          <a:solidFill>
+            <a:srgbClr val="FFFFFF">
+              <a:shade val="85000"/>
+            </a:srgbClr>
+          </a:solidFill>
+          <a:ln w="88900" cap="sq">
+            <a:solidFill>
+              <a:srgbClr val="FFFFFF"/>
+            </a:solidFill>
+            <a:miter lim="800000"/>
+          </a:ln>
+          <a:effectLst>
+            <a:outerShdw blurRad="55000" dist="18000" dir="5400000" algn="tl" rotWithShape="0">
+              <a:srgbClr val="000000">
+                <a:alpha val="40000"/>
+              </a:srgbClr>
+            </a:outerShdw>
+          </a:effectLst>
+          <a:scene3d>
+            <a:camera prst="orthographicFront"/>
+            <a:lightRig rig="twoPt" dir="t">
+              <a:rot lat="0" lon="0" rev="7200000"/>
+            </a:lightRig>
+          </a:scene3d>
+          <a:sp3d>
+            <a:bevelT w="25400" h="19050"/>
+            <a:contourClr>
+              <a:srgbClr val="FFFFFF"/>
+            </a:contourClr>
+          </a:sp3d>
+        </p:spPr>
+      </p:pic>
+    </p:spTree>
+    <p:extLst>
+      <p:ext uri="{BB962C8B-B14F-4D97-AF65-F5344CB8AC3E}">
+        <p14:creationId xmlns:p14="http://schemas.microsoft.com/office/powerpoint/2010/main" val="3260737732"/>
+      </p:ext>
+    </p:extLst>
+  </p:cSld>
+  <p:clrMapOvr>
+    <a:masterClrMapping/>
+  </p:clrMapOvr>
+</p:sld>
+</file>
+
+<file path=ppt/slides/slide11.xml><?xml version="1.0" encoding="utf-8"?>
+<p:sld xmlns:a="http://schemas.openxmlformats.org/drawingml/2006/main" xmlns:r="http://schemas.openxmlformats.org/officeDocument/2006/relationships" xmlns:p="http://schemas.openxmlformats.org/presentationml/2006/main">
+  <p:cSld>
+    <p:spTree>
+      <p:nvGrpSpPr>
+        <p:cNvPr id="1" name="">
+          <a:extLst>
+            <a:ext uri="{FF2B5EF4-FFF2-40B4-BE49-F238E27FC236}">
+              <a16:creationId xmlns:a16="http://schemas.microsoft.com/office/drawing/2014/main" id="{03B1775F-562C-A9D4-8460-8992899D7D3C}"/>
+            </a:ext>
+          </a:extLst>
+        </p:cNvPr>
+        <p:cNvGrpSpPr/>
+        <p:nvPr/>
+      </p:nvGrpSpPr>
+      <p:grpSpPr>
+        <a:xfrm>
+          <a:off x="0" y="0"/>
+          <a:ext cx="0" cy="0"/>
+          <a:chOff x="0" y="0"/>
+          <a:chExt cx="0" cy="0"/>
+        </a:xfrm>
+      </p:grpSpPr>
+      <p:sp>
+        <p:nvSpPr>
+          <p:cNvPr id="3" name="TextBox 2">
+            <a:extLst>
+              <a:ext uri="{FF2B5EF4-FFF2-40B4-BE49-F238E27FC236}">
+                <a16:creationId xmlns:a16="http://schemas.microsoft.com/office/drawing/2014/main" id="{08BDD00B-7046-B6FD-9AA4-2D558362BD59}"/>
+              </a:ext>
+            </a:extLst>
+          </p:cNvPr>
+          <p:cNvSpPr txBox="1"/>
+          <p:nvPr/>
+        </p:nvSpPr>
+        <p:spPr>
+          <a:xfrm>
+            <a:off x="0" y="0"/>
+            <a:ext cx="12192000" cy="355354"/>
+          </a:xfrm>
+          <a:prstGeom prst="rect">
+            <a:avLst/>
+          </a:prstGeom>
+          <a:noFill/>
+        </p:spPr>
+        <p:txBody>
+          <a:bodyPr wrap="square">
+            <a:spAutoFit/>
+          </a:bodyPr>
+          <a:lstStyle/>
+          <a:p>
+            <a:pPr>
+              <a:lnSpc>
+                <a:spcPct val="150000"/>
+              </a:lnSpc>
+              <a:buNone/>
+            </a:pPr>
+            <a:r>
+              <a:rPr kumimoji="0" lang="en-US" altLang="en-US" sz="1300" b="0" i="0" u="none" strike="noStrike" cap="none" normalizeH="0" baseline="0">
+                <a:ln>
+                  <a:noFill/>
+                </a:ln>
+                <a:solidFill>
+                  <a:schemeClr val="tx1"/>
+                </a:solidFill>
+                <a:effectLst/>
+                <a:latin typeface="Arial" panose="020B0604020202020204" pitchFamily="34" charset="0"/>
+              </a:rPr>
+              <a:t>.</a:t>
+            </a:r>
+          </a:p>
+        </p:txBody>
+      </p:sp>
+    </p:spTree>
+    <p:extLst>
+      <p:ext uri="{BB962C8B-B14F-4D97-AF65-F5344CB8AC3E}">
+        <p14:creationId xmlns:p14="http://schemas.microsoft.com/office/powerpoint/2010/main" val="2155432070"/>
+      </p:ext>
+    </p:extLst>
+  </p:cSld>
+  <p:clrMapOvr>
+    <a:masterClrMapping/>
+  </p:clrMapOvr>
+</p:sld>
+</file>
+
+<file path=ppt/slides/slide12.xml><?xml version="1.0" encoding="utf-8"?>
+<p:sld xmlns:a="http://schemas.openxmlformats.org/drawingml/2006/main" xmlns:r="http://schemas.openxmlformats.org/officeDocument/2006/relationships" xmlns:p="http://schemas.openxmlformats.org/presentationml/2006/main">
+  <p:cSld>
+    <p:spTree>
+      <p:nvGrpSpPr>
+        <p:cNvPr id="1" name="">
+          <a:extLst>
+            <a:ext uri="{FF2B5EF4-FFF2-40B4-BE49-F238E27FC236}">
+              <a16:creationId xmlns:a16="http://schemas.microsoft.com/office/drawing/2014/main" id="{234FC578-E916-157D-9E34-98C92603E544}"/>
+            </a:ext>
+          </a:extLst>
+        </p:cNvPr>
+        <p:cNvGrpSpPr/>
+        <p:nvPr/>
+      </p:nvGrpSpPr>
+      <p:grpSpPr>
+        <a:xfrm>
+          <a:off x="0" y="0"/>
+          <a:ext cx="0" cy="0"/>
+          <a:chOff x="0" y="0"/>
+          <a:chExt cx="0" cy="0"/>
+        </a:xfrm>
+      </p:grpSpPr>
+      <p:sp>
+        <p:nvSpPr>
+          <p:cNvPr id="3" name="TextBox 2">
+            <a:extLst>
+              <a:ext uri="{FF2B5EF4-FFF2-40B4-BE49-F238E27FC236}">
+                <a16:creationId xmlns:a16="http://schemas.microsoft.com/office/drawing/2014/main" id="{44E910EB-F8CF-72DB-1654-E9E111A3D87E}"/>
+              </a:ext>
+            </a:extLst>
+          </p:cNvPr>
+          <p:cNvSpPr txBox="1"/>
+          <p:nvPr/>
+        </p:nvSpPr>
+        <p:spPr>
+          <a:xfrm>
+            <a:off x="0" y="0"/>
+            <a:ext cx="12192000" cy="355354"/>
+          </a:xfrm>
+          <a:prstGeom prst="rect">
+            <a:avLst/>
+          </a:prstGeom>
+          <a:noFill/>
+        </p:spPr>
+        <p:txBody>
+          <a:bodyPr wrap="square">
+            <a:spAutoFit/>
+          </a:bodyPr>
+          <a:lstStyle/>
+          <a:p>
+            <a:pPr>
+              <a:lnSpc>
+                <a:spcPct val="150000"/>
+              </a:lnSpc>
+              <a:buNone/>
+            </a:pPr>
+            <a:r>
+              <a:rPr kumimoji="0" lang="en-US" altLang="en-US" sz="1300" b="0" i="0" u="none" strike="noStrike" cap="none" normalizeH="0" baseline="0">
+                <a:ln>
+                  <a:noFill/>
+                </a:ln>
+                <a:solidFill>
+                  <a:schemeClr val="tx1"/>
+                </a:solidFill>
+                <a:effectLst/>
+                <a:latin typeface="Arial" panose="020B0604020202020204" pitchFamily="34" charset="0"/>
+              </a:rPr>
+              <a:t>.</a:t>
+            </a:r>
+          </a:p>
+        </p:txBody>
+      </p:sp>
+    </p:spTree>
+    <p:extLst>
+      <p:ext uri="{BB962C8B-B14F-4D97-AF65-F5344CB8AC3E}">
+        <p14:creationId xmlns:p14="http://schemas.microsoft.com/office/powerpoint/2010/main" val="616314994"/>
       </p:ext>
     </p:extLst>
   </p:cSld>
@@ -3472,6 +3827,36 @@
           </a:p>
         </p:txBody>
       </p:sp>
+      <p:pic>
+        <p:nvPicPr>
+          <p:cNvPr id="4" name="Picture 3">
+            <a:extLst>
+              <a:ext uri="{FF2B5EF4-FFF2-40B4-BE49-F238E27FC236}">
+                <a16:creationId xmlns:a16="http://schemas.microsoft.com/office/drawing/2014/main" id="{60D01157-6D76-875C-C6AE-B089BA6BB2AE}"/>
+              </a:ext>
+            </a:extLst>
+          </p:cNvPr>
+          <p:cNvPicPr>
+            <a:picLocks noChangeAspect="1"/>
+          </p:cNvPicPr>
+          <p:nvPr/>
+        </p:nvPicPr>
+        <p:blipFill>
+          <a:blip r:embed="rId2"/>
+          <a:stretch>
+            <a:fillRect/>
+          </a:stretch>
+        </p:blipFill>
+        <p:spPr>
+          <a:xfrm>
+            <a:off x="0" y="929947"/>
+            <a:ext cx="12192000" cy="4998105"/>
+          </a:xfrm>
+          <a:prstGeom prst="rect">
+            <a:avLst/>
+          </a:prstGeom>
+        </p:spPr>
+      </p:pic>
     </p:spTree>
     <p:extLst>
       <p:ext uri="{BB962C8B-B14F-4D97-AF65-F5344CB8AC3E}">
@@ -3486,6 +3871,268 @@
 </file>
 
 <file path=ppt/slides/slide3.xml><?xml version="1.0" encoding="utf-8"?>
+<p:sld xmlns:a="http://schemas.openxmlformats.org/drawingml/2006/main" xmlns:r="http://schemas.openxmlformats.org/officeDocument/2006/relationships" xmlns:p="http://schemas.openxmlformats.org/presentationml/2006/main">
+  <p:cSld>
+    <p:spTree>
+      <p:nvGrpSpPr>
+        <p:cNvPr id="1" name="">
+          <a:extLst>
+            <a:ext uri="{FF2B5EF4-FFF2-40B4-BE49-F238E27FC236}">
+              <a16:creationId xmlns:a16="http://schemas.microsoft.com/office/drawing/2014/main" id="{878798DC-F52B-12B8-E10D-1B67CD078360}"/>
+            </a:ext>
+          </a:extLst>
+        </p:cNvPr>
+        <p:cNvGrpSpPr/>
+        <p:nvPr/>
+      </p:nvGrpSpPr>
+      <p:grpSpPr>
+        <a:xfrm>
+          <a:off x="0" y="0"/>
+          <a:ext cx="0" cy="0"/>
+          <a:chOff x="0" y="0"/>
+          <a:chExt cx="0" cy="0"/>
+        </a:xfrm>
+      </p:grpSpPr>
+      <p:sp>
+        <p:nvSpPr>
+          <p:cNvPr id="3" name="TextBox 2">
+            <a:extLst>
+              <a:ext uri="{FF2B5EF4-FFF2-40B4-BE49-F238E27FC236}">
+                <a16:creationId xmlns:a16="http://schemas.microsoft.com/office/drawing/2014/main" id="{8B8BAC01-0BA0-4E85-C400-212538BC6A54}"/>
+              </a:ext>
+            </a:extLst>
+          </p:cNvPr>
+          <p:cNvSpPr txBox="1"/>
+          <p:nvPr/>
+        </p:nvSpPr>
+        <p:spPr>
+          <a:xfrm>
+            <a:off x="0" y="0"/>
+            <a:ext cx="12192000" cy="355354"/>
+          </a:xfrm>
+          <a:prstGeom prst="rect">
+            <a:avLst/>
+          </a:prstGeom>
+          <a:noFill/>
+        </p:spPr>
+        <p:txBody>
+          <a:bodyPr wrap="square">
+            <a:spAutoFit/>
+          </a:bodyPr>
+          <a:lstStyle/>
+          <a:p>
+            <a:pPr>
+              <a:lnSpc>
+                <a:spcPct val="150000"/>
+              </a:lnSpc>
+              <a:buNone/>
+            </a:pPr>
+            <a:r>
+              <a:rPr kumimoji="0" lang="en-US" altLang="en-US" sz="1300" b="0" i="0" u="none" strike="noStrike" cap="none" normalizeH="0" baseline="0">
+                <a:ln>
+                  <a:noFill/>
+                </a:ln>
+                <a:solidFill>
+                  <a:schemeClr val="tx1"/>
+                </a:solidFill>
+                <a:effectLst/>
+                <a:latin typeface="Arial" panose="020B0604020202020204" pitchFamily="34" charset="0"/>
+              </a:rPr>
+              <a:t>.</a:t>
+            </a:r>
+          </a:p>
+        </p:txBody>
+      </p:sp>
+      <p:pic>
+        <p:nvPicPr>
+          <p:cNvPr id="4" name="Picture 3">
+            <a:extLst>
+              <a:ext uri="{FF2B5EF4-FFF2-40B4-BE49-F238E27FC236}">
+                <a16:creationId xmlns:a16="http://schemas.microsoft.com/office/drawing/2014/main" id="{47E8C6A4-3188-F3E2-9F7B-44DFF6F10B09}"/>
+              </a:ext>
+            </a:extLst>
+          </p:cNvPr>
+          <p:cNvPicPr>
+            <a:picLocks noChangeAspect="1"/>
+          </p:cNvPicPr>
+          <p:nvPr/>
+        </p:nvPicPr>
+        <p:blipFill>
+          <a:blip r:embed="rId2"/>
+          <a:stretch>
+            <a:fillRect/>
+          </a:stretch>
+        </p:blipFill>
+        <p:spPr>
+          <a:xfrm>
+            <a:off x="1050272" y="0"/>
+            <a:ext cx="10091456" cy="6858000"/>
+          </a:xfrm>
+          <a:prstGeom prst="rect">
+            <a:avLst/>
+          </a:prstGeom>
+        </p:spPr>
+      </p:pic>
+    </p:spTree>
+    <p:extLst>
+      <p:ext uri="{BB962C8B-B14F-4D97-AF65-F5344CB8AC3E}">
+        <p14:creationId xmlns:p14="http://schemas.microsoft.com/office/powerpoint/2010/main" val="3922938825"/>
+      </p:ext>
+    </p:extLst>
+  </p:cSld>
+  <p:clrMapOvr>
+    <a:masterClrMapping/>
+  </p:clrMapOvr>
+</p:sld>
+</file>
+
+<file path=ppt/slides/slide4.xml><?xml version="1.0" encoding="utf-8"?>
+<p:sld xmlns:a="http://schemas.openxmlformats.org/drawingml/2006/main" xmlns:r="http://schemas.openxmlformats.org/officeDocument/2006/relationships" xmlns:p="http://schemas.openxmlformats.org/presentationml/2006/main">
+  <p:cSld>
+    <p:spTree>
+      <p:nvGrpSpPr>
+        <p:cNvPr id="1" name="">
+          <a:extLst>
+            <a:ext uri="{FF2B5EF4-FFF2-40B4-BE49-F238E27FC236}">
+              <a16:creationId xmlns:a16="http://schemas.microsoft.com/office/drawing/2014/main" id="{13294E31-EAD9-22EC-D8B7-398EBF3A3EDD}"/>
+            </a:ext>
+          </a:extLst>
+        </p:cNvPr>
+        <p:cNvGrpSpPr/>
+        <p:nvPr/>
+      </p:nvGrpSpPr>
+      <p:grpSpPr>
+        <a:xfrm>
+          <a:off x="0" y="0"/>
+          <a:ext cx="0" cy="0"/>
+          <a:chOff x="0" y="0"/>
+          <a:chExt cx="0" cy="0"/>
+        </a:xfrm>
+      </p:grpSpPr>
+      <p:sp>
+        <p:nvSpPr>
+          <p:cNvPr id="3" name="TextBox 2">
+            <a:extLst>
+              <a:ext uri="{FF2B5EF4-FFF2-40B4-BE49-F238E27FC236}">
+                <a16:creationId xmlns:a16="http://schemas.microsoft.com/office/drawing/2014/main" id="{9657B145-3D6F-70D6-972C-CCAED9A859C3}"/>
+              </a:ext>
+            </a:extLst>
+          </p:cNvPr>
+          <p:cNvSpPr txBox="1"/>
+          <p:nvPr/>
+        </p:nvSpPr>
+        <p:spPr>
+          <a:xfrm>
+            <a:off x="0" y="0"/>
+            <a:ext cx="12192000" cy="355354"/>
+          </a:xfrm>
+          <a:prstGeom prst="rect">
+            <a:avLst/>
+          </a:prstGeom>
+          <a:noFill/>
+        </p:spPr>
+        <p:txBody>
+          <a:bodyPr wrap="square">
+            <a:spAutoFit/>
+          </a:bodyPr>
+          <a:lstStyle/>
+          <a:p>
+            <a:pPr>
+              <a:lnSpc>
+                <a:spcPct val="150000"/>
+              </a:lnSpc>
+              <a:buNone/>
+            </a:pPr>
+            <a:r>
+              <a:rPr kumimoji="0" lang="en-US" altLang="en-US" sz="1300" b="0" i="0" u="none" strike="noStrike" cap="none" normalizeH="0" baseline="0">
+                <a:ln>
+                  <a:noFill/>
+                </a:ln>
+                <a:solidFill>
+                  <a:schemeClr val="tx1"/>
+                </a:solidFill>
+                <a:effectLst/>
+                <a:latin typeface="Arial" panose="020B0604020202020204" pitchFamily="34" charset="0"/>
+              </a:rPr>
+              <a:t>.</a:t>
+            </a:r>
+          </a:p>
+        </p:txBody>
+      </p:sp>
+      <p:pic>
+        <p:nvPicPr>
+          <p:cNvPr id="4" name="Picture 3">
+            <a:extLst>
+              <a:ext uri="{FF2B5EF4-FFF2-40B4-BE49-F238E27FC236}">
+                <a16:creationId xmlns:a16="http://schemas.microsoft.com/office/drawing/2014/main" id="{759E6E30-9B59-8003-5A48-F126B2B0A5AE}"/>
+              </a:ext>
+            </a:extLst>
+          </p:cNvPr>
+          <p:cNvPicPr>
+            <a:picLocks noChangeAspect="1"/>
+          </p:cNvPicPr>
+          <p:nvPr/>
+        </p:nvPicPr>
+        <p:blipFill>
+          <a:blip r:embed="rId2"/>
+          <a:stretch>
+            <a:fillRect/>
+          </a:stretch>
+        </p:blipFill>
+        <p:spPr>
+          <a:xfrm>
+            <a:off x="239452" y="0"/>
+            <a:ext cx="11713096" cy="6858000"/>
+          </a:xfrm>
+          <a:prstGeom prst="rect">
+            <a:avLst/>
+          </a:prstGeom>
+          <a:solidFill>
+            <a:srgbClr val="FFFFFF">
+              <a:shade val="85000"/>
+            </a:srgbClr>
+          </a:solidFill>
+          <a:ln w="88900" cap="sq">
+            <a:solidFill>
+              <a:srgbClr val="FFFFFF"/>
+            </a:solidFill>
+            <a:miter lim="800000"/>
+          </a:ln>
+          <a:effectLst>
+            <a:outerShdw blurRad="55000" dist="18000" dir="5400000" algn="tl" rotWithShape="0">
+              <a:srgbClr val="000000">
+                <a:alpha val="40000"/>
+              </a:srgbClr>
+            </a:outerShdw>
+          </a:effectLst>
+          <a:scene3d>
+            <a:camera prst="orthographicFront"/>
+            <a:lightRig rig="twoPt" dir="t">
+              <a:rot lat="0" lon="0" rev="7200000"/>
+            </a:lightRig>
+          </a:scene3d>
+          <a:sp3d>
+            <a:bevelT w="25400" h="19050"/>
+            <a:contourClr>
+              <a:srgbClr val="FFFFFF"/>
+            </a:contourClr>
+          </a:sp3d>
+        </p:spPr>
+      </p:pic>
+    </p:spTree>
+    <p:extLst>
+      <p:ext uri="{BB962C8B-B14F-4D97-AF65-F5344CB8AC3E}">
+        <p14:creationId xmlns:p14="http://schemas.microsoft.com/office/powerpoint/2010/main" val="856954804"/>
+      </p:ext>
+    </p:extLst>
+  </p:cSld>
+  <p:clrMapOvr>
+    <a:masterClrMapping/>
+  </p:clrMapOvr>
+</p:sld>
+</file>
+
+<file path=ppt/slides/slide5.xml><?xml version="1.0" encoding="utf-8"?>
 <p:sld xmlns:a="http://schemas.openxmlformats.org/drawingml/2006/main" xmlns:r="http://schemas.openxmlformats.org/officeDocument/2006/relationships" xmlns:p="http://schemas.openxmlformats.org/presentationml/2006/main">
   <p:cSld>
     <p:spTree>
@@ -3558,6 +4205,36 @@
           </a:p>
         </p:txBody>
       </p:sp>
+      <p:pic>
+        <p:nvPicPr>
+          <p:cNvPr id="4" name="Picture 3">
+            <a:extLst>
+              <a:ext uri="{FF2B5EF4-FFF2-40B4-BE49-F238E27FC236}">
+                <a16:creationId xmlns:a16="http://schemas.microsoft.com/office/drawing/2014/main" id="{D747AB22-6785-4692-D252-492111C8F1FE}"/>
+              </a:ext>
+            </a:extLst>
+          </p:cNvPr>
+          <p:cNvPicPr>
+            <a:picLocks noChangeAspect="1"/>
+          </p:cNvPicPr>
+          <p:nvPr/>
+        </p:nvPicPr>
+        <p:blipFill>
+          <a:blip r:embed="rId2"/>
+          <a:stretch>
+            <a:fillRect/>
+          </a:stretch>
+        </p:blipFill>
+        <p:spPr>
+          <a:xfrm>
+            <a:off x="1618376" y="0"/>
+            <a:ext cx="8955248" cy="6858000"/>
+          </a:xfrm>
+          <a:prstGeom prst="rect">
+            <a:avLst/>
+          </a:prstGeom>
+        </p:spPr>
+      </p:pic>
     </p:spTree>
     <p:extLst>
       <p:ext uri="{BB962C8B-B14F-4D97-AF65-F5344CB8AC3E}">
@@ -3571,7 +4248,7 @@
 </p:sld>
 </file>
 
-<file path=ppt/slides/slide4.xml><?xml version="1.0" encoding="utf-8"?>
+<file path=ppt/slides/slide6.xml><?xml version="1.0" encoding="utf-8"?>
 <p:sld xmlns:a="http://schemas.openxmlformats.org/drawingml/2006/main" xmlns:r="http://schemas.openxmlformats.org/officeDocument/2006/relationships" xmlns:p="http://schemas.openxmlformats.org/presentationml/2006/main">
   <p:cSld>
     <p:spTree>
@@ -3579,7 +4256,7 @@
         <p:cNvPr id="1" name="">
           <a:extLst>
             <a:ext uri="{FF2B5EF4-FFF2-40B4-BE49-F238E27FC236}">
-              <a16:creationId xmlns:a16="http://schemas.microsoft.com/office/drawing/2014/main" id="{03B1775F-562C-A9D4-8460-8992899D7D3C}"/>
+              <a16:creationId xmlns:a16="http://schemas.microsoft.com/office/drawing/2014/main" id="{BFA0C7AB-D1D4-0F9A-AABE-0EB61E6F8AF3}"/>
             </a:ext>
           </a:extLst>
         </p:cNvPr>
@@ -3599,7 +4276,7 @@
           <p:cNvPr id="3" name="TextBox 2">
             <a:extLst>
               <a:ext uri="{FF2B5EF4-FFF2-40B4-BE49-F238E27FC236}">
-                <a16:creationId xmlns:a16="http://schemas.microsoft.com/office/drawing/2014/main" id="{08BDD00B-7046-B6FD-9AA4-2D558362BD59}"/>
+                <a16:creationId xmlns:a16="http://schemas.microsoft.com/office/drawing/2014/main" id="{A8CDBD6C-EF61-240B-8C8F-1260DB2347E6}"/>
               </a:ext>
             </a:extLst>
           </p:cNvPr>
@@ -3644,10 +4321,40 @@
           </a:p>
         </p:txBody>
       </p:sp>
+      <p:pic>
+        <p:nvPicPr>
+          <p:cNvPr id="4" name="Picture 3">
+            <a:extLst>
+              <a:ext uri="{FF2B5EF4-FFF2-40B4-BE49-F238E27FC236}">
+                <a16:creationId xmlns:a16="http://schemas.microsoft.com/office/drawing/2014/main" id="{F1D6ABFF-74C4-A4A0-FF9D-9A2D9552DB56}"/>
+              </a:ext>
+            </a:extLst>
+          </p:cNvPr>
+          <p:cNvPicPr>
+            <a:picLocks noChangeAspect="1"/>
+          </p:cNvPicPr>
+          <p:nvPr/>
+        </p:nvPicPr>
+        <p:blipFill>
+          <a:blip r:embed="rId2"/>
+          <a:stretch>
+            <a:fillRect/>
+          </a:stretch>
+        </p:blipFill>
+        <p:spPr>
+          <a:xfrm>
+            <a:off x="1383733" y="0"/>
+            <a:ext cx="9424533" cy="6858000"/>
+          </a:xfrm>
+          <a:prstGeom prst="rect">
+            <a:avLst/>
+          </a:prstGeom>
+        </p:spPr>
+      </p:pic>
     </p:spTree>
     <p:extLst>
       <p:ext uri="{BB962C8B-B14F-4D97-AF65-F5344CB8AC3E}">
-        <p14:creationId xmlns:p14="http://schemas.microsoft.com/office/powerpoint/2010/main" val="2155432070"/>
+        <p14:creationId xmlns:p14="http://schemas.microsoft.com/office/powerpoint/2010/main" val="3790815984"/>
       </p:ext>
     </p:extLst>
   </p:cSld>
@@ -3657,7 +4364,7 @@
 </p:sld>
 </file>
 
-<file path=ppt/slides/slide5.xml><?xml version="1.0" encoding="utf-8"?>
+<file path=ppt/slides/slide7.xml><?xml version="1.0" encoding="utf-8"?>
 <p:sld xmlns:a="http://schemas.openxmlformats.org/drawingml/2006/main" xmlns:r="http://schemas.openxmlformats.org/officeDocument/2006/relationships" xmlns:p="http://schemas.openxmlformats.org/presentationml/2006/main">
   <p:cSld>
     <p:spTree>
@@ -3665,7 +4372,7 @@
         <p:cNvPr id="1" name="">
           <a:extLst>
             <a:ext uri="{FF2B5EF4-FFF2-40B4-BE49-F238E27FC236}">
-              <a16:creationId xmlns:a16="http://schemas.microsoft.com/office/drawing/2014/main" id="{234FC578-E916-157D-9E34-98C92603E544}"/>
+              <a16:creationId xmlns:a16="http://schemas.microsoft.com/office/drawing/2014/main" id="{EDD78CB8-09D9-796F-DE5D-30D0F7E330CC}"/>
             </a:ext>
           </a:extLst>
         </p:cNvPr>
@@ -3685,7 +4392,7 @@
           <p:cNvPr id="3" name="TextBox 2">
             <a:extLst>
               <a:ext uri="{FF2B5EF4-FFF2-40B4-BE49-F238E27FC236}">
-                <a16:creationId xmlns:a16="http://schemas.microsoft.com/office/drawing/2014/main" id="{44E910EB-F8CF-72DB-1654-E9E111A3D87E}"/>
+                <a16:creationId xmlns:a16="http://schemas.microsoft.com/office/drawing/2014/main" id="{9B334C79-4A34-6391-0AE4-3E1E6BC4B1EE}"/>
               </a:ext>
             </a:extLst>
           </p:cNvPr>
@@ -3730,10 +4437,272 @@
           </a:p>
         </p:txBody>
       </p:sp>
+      <p:pic>
+        <p:nvPicPr>
+          <p:cNvPr id="4" name="Picture 3">
+            <a:extLst>
+              <a:ext uri="{FF2B5EF4-FFF2-40B4-BE49-F238E27FC236}">
+                <a16:creationId xmlns:a16="http://schemas.microsoft.com/office/drawing/2014/main" id="{57CF6C04-BAE7-3040-69BA-792310A4B8EB}"/>
+              </a:ext>
+            </a:extLst>
+          </p:cNvPr>
+          <p:cNvPicPr>
+            <a:picLocks noChangeAspect="1"/>
+          </p:cNvPicPr>
+          <p:nvPr/>
+        </p:nvPicPr>
+        <p:blipFill>
+          <a:blip r:embed="rId2"/>
+          <a:stretch>
+            <a:fillRect/>
+          </a:stretch>
+        </p:blipFill>
+        <p:spPr>
+          <a:xfrm>
+            <a:off x="1468958" y="0"/>
+            <a:ext cx="9254084" cy="6858000"/>
+          </a:xfrm>
+          <a:prstGeom prst="rect">
+            <a:avLst/>
+          </a:prstGeom>
+        </p:spPr>
+      </p:pic>
     </p:spTree>
     <p:extLst>
       <p:ext uri="{BB962C8B-B14F-4D97-AF65-F5344CB8AC3E}">
-        <p14:creationId xmlns:p14="http://schemas.microsoft.com/office/powerpoint/2010/main" val="616314994"/>
+        <p14:creationId xmlns:p14="http://schemas.microsoft.com/office/powerpoint/2010/main" val="3474352945"/>
+      </p:ext>
+    </p:extLst>
+  </p:cSld>
+  <p:clrMapOvr>
+    <a:masterClrMapping/>
+  </p:clrMapOvr>
+</p:sld>
+</file>
+
+<file path=ppt/slides/slide8.xml><?xml version="1.0" encoding="utf-8"?>
+<p:sld xmlns:a="http://schemas.openxmlformats.org/drawingml/2006/main" xmlns:r="http://schemas.openxmlformats.org/officeDocument/2006/relationships" xmlns:p="http://schemas.openxmlformats.org/presentationml/2006/main">
+  <p:cSld>
+    <p:spTree>
+      <p:nvGrpSpPr>
+        <p:cNvPr id="1" name="">
+          <a:extLst>
+            <a:ext uri="{FF2B5EF4-FFF2-40B4-BE49-F238E27FC236}">
+              <a16:creationId xmlns:a16="http://schemas.microsoft.com/office/drawing/2014/main" id="{48BE6195-F56E-87D4-F7AA-C7C5EE96FBAD}"/>
+            </a:ext>
+          </a:extLst>
+        </p:cNvPr>
+        <p:cNvGrpSpPr/>
+        <p:nvPr/>
+      </p:nvGrpSpPr>
+      <p:grpSpPr>
+        <a:xfrm>
+          <a:off x="0" y="0"/>
+          <a:ext cx="0" cy="0"/>
+          <a:chOff x="0" y="0"/>
+          <a:chExt cx="0" cy="0"/>
+        </a:xfrm>
+      </p:grpSpPr>
+      <p:sp>
+        <p:nvSpPr>
+          <p:cNvPr id="3" name="TextBox 2">
+            <a:extLst>
+              <a:ext uri="{FF2B5EF4-FFF2-40B4-BE49-F238E27FC236}">
+                <a16:creationId xmlns:a16="http://schemas.microsoft.com/office/drawing/2014/main" id="{02ABBCCB-03D0-D84A-E55F-2C4BDA6747F6}"/>
+              </a:ext>
+            </a:extLst>
+          </p:cNvPr>
+          <p:cNvSpPr txBox="1"/>
+          <p:nvPr/>
+        </p:nvSpPr>
+        <p:spPr>
+          <a:xfrm>
+            <a:off x="0" y="0"/>
+            <a:ext cx="12192000" cy="355354"/>
+          </a:xfrm>
+          <a:prstGeom prst="rect">
+            <a:avLst/>
+          </a:prstGeom>
+          <a:noFill/>
+        </p:spPr>
+        <p:txBody>
+          <a:bodyPr wrap="square">
+            <a:spAutoFit/>
+          </a:bodyPr>
+          <a:lstStyle/>
+          <a:p>
+            <a:pPr>
+              <a:lnSpc>
+                <a:spcPct val="150000"/>
+              </a:lnSpc>
+              <a:buNone/>
+            </a:pPr>
+            <a:r>
+              <a:rPr kumimoji="0" lang="en-US" altLang="en-US" sz="1300" b="0" i="0" u="none" strike="noStrike" cap="none" normalizeH="0" baseline="0">
+                <a:ln>
+                  <a:noFill/>
+                </a:ln>
+                <a:solidFill>
+                  <a:schemeClr val="tx1"/>
+                </a:solidFill>
+                <a:effectLst/>
+                <a:latin typeface="Arial" panose="020B0604020202020204" pitchFamily="34" charset="0"/>
+              </a:rPr>
+              <a:t>.</a:t>
+            </a:r>
+          </a:p>
+        </p:txBody>
+      </p:sp>
+      <p:pic>
+        <p:nvPicPr>
+          <p:cNvPr id="4" name="Picture 3">
+            <a:extLst>
+              <a:ext uri="{FF2B5EF4-FFF2-40B4-BE49-F238E27FC236}">
+                <a16:creationId xmlns:a16="http://schemas.microsoft.com/office/drawing/2014/main" id="{5A45F32E-CAF5-06E6-305C-5232705D0FB6}"/>
+              </a:ext>
+            </a:extLst>
+          </p:cNvPr>
+          <p:cNvPicPr>
+            <a:picLocks noChangeAspect="1"/>
+          </p:cNvPicPr>
+          <p:nvPr/>
+        </p:nvPicPr>
+        <p:blipFill>
+          <a:blip r:embed="rId2"/>
+          <a:stretch>
+            <a:fillRect/>
+          </a:stretch>
+        </p:blipFill>
+        <p:spPr>
+          <a:xfrm>
+            <a:off x="1493551" y="0"/>
+            <a:ext cx="9204897" cy="6858000"/>
+          </a:xfrm>
+          <a:prstGeom prst="rect">
+            <a:avLst/>
+          </a:prstGeom>
+        </p:spPr>
+      </p:pic>
+    </p:spTree>
+    <p:extLst>
+      <p:ext uri="{BB962C8B-B14F-4D97-AF65-F5344CB8AC3E}">
+        <p14:creationId xmlns:p14="http://schemas.microsoft.com/office/powerpoint/2010/main" val="2619022670"/>
+      </p:ext>
+    </p:extLst>
+  </p:cSld>
+  <p:clrMapOvr>
+    <a:masterClrMapping/>
+  </p:clrMapOvr>
+</p:sld>
+</file>
+
+<file path=ppt/slides/slide9.xml><?xml version="1.0" encoding="utf-8"?>
+<p:sld xmlns:a="http://schemas.openxmlformats.org/drawingml/2006/main" xmlns:r="http://schemas.openxmlformats.org/officeDocument/2006/relationships" xmlns:p="http://schemas.openxmlformats.org/presentationml/2006/main">
+  <p:cSld>
+    <p:spTree>
+      <p:nvGrpSpPr>
+        <p:cNvPr id="1" name="">
+          <a:extLst>
+            <a:ext uri="{FF2B5EF4-FFF2-40B4-BE49-F238E27FC236}">
+              <a16:creationId xmlns:a16="http://schemas.microsoft.com/office/drawing/2014/main" id="{3577C297-0A42-2AF6-6C96-4330AD423C1F}"/>
+            </a:ext>
+          </a:extLst>
+        </p:cNvPr>
+        <p:cNvGrpSpPr/>
+        <p:nvPr/>
+      </p:nvGrpSpPr>
+      <p:grpSpPr>
+        <a:xfrm>
+          <a:off x="0" y="0"/>
+          <a:ext cx="0" cy="0"/>
+          <a:chOff x="0" y="0"/>
+          <a:chExt cx="0" cy="0"/>
+        </a:xfrm>
+      </p:grpSpPr>
+      <p:sp>
+        <p:nvSpPr>
+          <p:cNvPr id="3" name="TextBox 2">
+            <a:extLst>
+              <a:ext uri="{FF2B5EF4-FFF2-40B4-BE49-F238E27FC236}">
+                <a16:creationId xmlns:a16="http://schemas.microsoft.com/office/drawing/2014/main" id="{9F5EED86-A840-37BD-07DE-05CFA14E3C56}"/>
+              </a:ext>
+            </a:extLst>
+          </p:cNvPr>
+          <p:cNvSpPr txBox="1"/>
+          <p:nvPr/>
+        </p:nvSpPr>
+        <p:spPr>
+          <a:xfrm>
+            <a:off x="0" y="0"/>
+            <a:ext cx="12192000" cy="355354"/>
+          </a:xfrm>
+          <a:prstGeom prst="rect">
+            <a:avLst/>
+          </a:prstGeom>
+          <a:noFill/>
+        </p:spPr>
+        <p:txBody>
+          <a:bodyPr wrap="square">
+            <a:spAutoFit/>
+          </a:bodyPr>
+          <a:lstStyle/>
+          <a:p>
+            <a:pPr>
+              <a:lnSpc>
+                <a:spcPct val="150000"/>
+              </a:lnSpc>
+              <a:buNone/>
+            </a:pPr>
+            <a:r>
+              <a:rPr kumimoji="0" lang="en-US" altLang="en-US" sz="1300" b="0" i="0" u="none" strike="noStrike" cap="none" normalizeH="0" baseline="0">
+                <a:ln>
+                  <a:noFill/>
+                </a:ln>
+                <a:solidFill>
+                  <a:schemeClr val="tx1"/>
+                </a:solidFill>
+                <a:effectLst/>
+                <a:latin typeface="Arial" panose="020B0604020202020204" pitchFamily="34" charset="0"/>
+              </a:rPr>
+              <a:t>.</a:t>
+            </a:r>
+          </a:p>
+        </p:txBody>
+      </p:sp>
+      <p:pic>
+        <p:nvPicPr>
+          <p:cNvPr id="4" name="Picture 3">
+            <a:extLst>
+              <a:ext uri="{FF2B5EF4-FFF2-40B4-BE49-F238E27FC236}">
+                <a16:creationId xmlns:a16="http://schemas.microsoft.com/office/drawing/2014/main" id="{A592926B-7E00-306B-D837-038BFEEE5961}"/>
+              </a:ext>
+            </a:extLst>
+          </p:cNvPr>
+          <p:cNvPicPr>
+            <a:picLocks noChangeAspect="1"/>
+          </p:cNvPicPr>
+          <p:nvPr/>
+        </p:nvPicPr>
+        <p:blipFill>
+          <a:blip r:embed="rId2"/>
+          <a:stretch>
+            <a:fillRect/>
+          </a:stretch>
+        </p:blipFill>
+        <p:spPr>
+          <a:xfrm>
+            <a:off x="0" y="237564"/>
+            <a:ext cx="12192000" cy="6382871"/>
+          </a:xfrm>
+          <a:prstGeom prst="rect">
+            <a:avLst/>
+          </a:prstGeom>
+        </p:spPr>
+      </p:pic>
+    </p:spTree>
+    <p:extLst>
+      <p:ext uri="{BB962C8B-B14F-4D97-AF65-F5344CB8AC3E}">
+        <p14:creationId xmlns:p14="http://schemas.microsoft.com/office/powerpoint/2010/main" val="257389373"/>
       </p:ext>
     </p:extLst>
   </p:cSld>

</xml_diff>